<commit_message>
Add student replication, risk calculator, speaker notes and defense guide
Uses all three hackathon datasets: replicates the employment null result
on the student longitudinal panel. Adds a coefficient-only interactive
risk calculator for the defense demo, speaker notes on every slide, and
a defense cheat sheet with likely jury questions.

Co-Authored-By: Claude Opus 5.5 <noreply@anthropic.com>
Claude-Session: https://claude.ai/code/session_01PZDWKKgiJuqfG7omCLEEiz
</commit_message>
<xml_diff>
--- a/output/IVO2026_aspiranty_dropout.pptx
+++ b/output/IVO2026_aspiranty_dropout.pptx
@@ -116,23 +116,23 @@
   <p:extLst>
     <p:ext uri="{521415D9-36F7-43E2-AB2F-B90AF26B5E84}">
       <p14:sectionLst xmlns:p14="http://schemas.microsoft.com/office/powerpoint/2010/main">
-        <p14:section name="Вступление" id="{f612aba6-fcfa-292c-7b15-88d4eb232e9b}">
+        <p14:section name="Вступление" id="{c5bae37e-839f-d1e1-459a-e68588cf2795}">
           <p14:sldIdLst>
             <p14:sldId id="256"/>
           </p14:sldIdLst>
         </p14:section>
-        <p14:section name="Вопрос и данные" id="{8c3f5aa2-ffe7-68a0-ac91-56741371e234}">
+        <p14:section name="Вопрос и данные" id="{9f3d3219-19e5-6379-3d1b-c4ee5362a361}">
           <p14:sldIdLst>
             <p14:sldId id="257"/>
             <p14:sldId id="258"/>
           </p14:sldIdLst>
         </p14:section>
-        <p14:section name="Методы" id="{4f60ec3f-d6e9-aa45-7a7e-c6e1bd9ffa53}">
+        <p14:section name="Методы" id="{6db80f17-673a-cf09-3ed7-d939f3299ff1}">
           <p14:sldIdLst>
             <p14:sldId id="259"/>
           </p14:sldIdLst>
         </p14:section>
-        <p14:section name="Результаты" id="{6f5a06c4-84ce-c25b-4144-e2ed74758c9a}">
+        <p14:section name="Результаты" id="{3a467fc7-25c9-13c5-7c97-aedfcc7b519d}">
           <p14:sldIdLst>
             <p14:sldId id="260"/>
             <p14:sldId id="261"/>
@@ -141,7 +141,7 @@
             <p14:sldId id="264"/>
           </p14:sldIdLst>
         </p14:section>
-        <p14:section name="Выводы" id="{b78d92bd-abbf-d8ce-e8e9-d4344bb0729e}">
+        <p14:section name="Выводы" id="{6e975efc-28e8-c59c-fc97-afbb26e034e4}">
           <p14:sldIdLst>
             <p14:sldId id="265"/>
           </p14:sldIdLst>
@@ -2182,7 +2182,7 @@
           <a:p>
             <a:r>
               <a:rPr lang="en-US" dirty="0"/>
-              <a:t>Главная мысль за 10 секунд: работа почти не связана с желанием уйти; решают руководитель, академическое сообщество и ментальное здоровье, а вузы с «конвейером защит» усиливают риск.</a:t>
+              <a:t>Добрый вечер. Я Егор, участвую один. Мой вопрос: почему аспиранты хотят бросить аспирантуру. Короткий ответ на 10 секунд: не из-за работы. Решают научный руководитель, чувство своей кафедры и ментальное здоровье. А ещё сам вуз: в «конвейерах защит» риск выше. Я связал все три массива хакатона.</a:t>
             </a:r>
             <a:endParaRPr lang="en-US" dirty="0"/>
           </a:p>
@@ -2270,7 +2270,7 @@
           <a:p>
             <a:r>
               <a:rPr lang="en-US" dirty="0"/>
-              <a:t/>
+              <a:t>Что делать. Я посчитал меры на модели. Комплекс из встреч с руководителем, сообщества кафедры и психологической помощи снижает долю желающих уйти с 20 до 13 процентов. Уход с работы не даёт ничего. Для защиты я сделал интерактивный калькулятор риска: могу показать его вживую. Спасибо!</a:t>
             </a:r>
             <a:endParaRPr lang="en-US" dirty="0"/>
           </a:p>
@@ -2358,7 +2358,7 @@
           <a:p>
             <a:r>
               <a:rPr lang="en-US" dirty="0"/>
-              <a:t/>
+              <a:t>Меньше пятой части аспирантов защищается в срок. Намерение уйти появляется раньше отчисления, значит, его можно поймать. Самое частое объяснение отсева: «они работают». Я проверил пять гипотез: от работы до эффекта самого вуза.</a:t>
             </a:r>
             <a:endParaRPr lang="en-US" dirty="0"/>
           </a:p>
@@ -2446,7 +2446,7 @@
           <a:p>
             <a:r>
               <a:rPr lang="en-US" dirty="0"/>
-              <a:t/>
+              <a:t>Основа: опрос 5 007 аспирантов из 249 вузов, 2021 год. Я сопоставил названия вузов с Мониторингом эффективности за тот же год и получил связанный массив: 85 вузов и 3 570 человек. Лонгитюд студентов использую для репликации. Каждый пятый аспирант часто хочет уйти, у каждого четвёртого умеренные и выше депрессивные симптомы.</a:t>
             </a:r>
             <a:endParaRPr lang="en-US" dirty="0"/>
           </a:p>
@@ -2534,7 +2534,7 @@
           <a:p>
             <a:r>
               <a:rPr lang="en-US" dirty="0"/>
-              <a:t/>
+              <a:t>Методов семь, и у каждого свой вопрос. Логит отвечает, что связано. Шепли показывает, что важнее. Бустинг проверяет предсказуемость и нелинейности. Кластеры показывают, кто в группе риска. Медиация объясняет, как это работает. Многоуровневая модель проверяет роль вуза. G-computation считает, что дадут меры.</a:t>
             </a:r>
             <a:endParaRPr lang="en-US" dirty="0"/>
           </a:p>
@@ -2622,7 +2622,7 @@
           <a:p>
             <a:r>
               <a:rPr lang="en-US" dirty="0"/>
-              <a:t/>
+              <a:t>Главный слайд. Слева тип занятости: от 20 до 24 процентов, разницы почти нет. Справа руководитель, кафедра и симптомы: разброс в четыре–шесть раз. Сопоставление похожих аспирантов даёт эффект работы около нуля. На студентах начало работы тоже не повышает мысли об уходе. Важна не работа, а переживание конфликта.</a:t>
             </a:r>
             <a:endParaRPr lang="en-US" dirty="0"/>
           </a:p>
@@ -2710,7 +2710,7 @@
           <a:p>
             <a:r>
               <a:rPr lang="en-US" dirty="0"/>
-              <a:t/>
+              <a:t>Разложение Шепли: здоровье, среда и руководитель дают две трети объяснённого, занятость меньше двух процентов. Модель хорошо различает группы: AUC 0.83, а только на внешних факторах 0.61. Пятая часть аспирантов с самым высоким прогнозом риска покрывает больше половины желающих уйти. E-value около двух: связь не объяснить слабым скрытым фактором.</a:t>
             </a:r>
             <a:endParaRPr lang="en-US" dirty="0"/>
           </a:p>
@@ -2798,7 +2798,7 @@
           <a:p>
             <a:r>
               <a:rPr lang="en-US" dirty="0"/>
-              <a:t/>
+              <a:t>Четыре типа аспирантов. Почти половина вовлечены, и уйти хотят всего 5%. Отстранённые: с руководителем всё нормально, но нет своей кафедры. Выгорающие: среда хорошая, но выраженные симптомы. И 10% без опоры на руководителя: там уйти хотят 59%. Доля работающих во всех четырёх группах около 45%.</a:t>
             </a:r>
             <a:endParaRPr lang="en-US" dirty="0"/>
           </a:p>
@@ -2886,7 +2886,7 @@
           <a:p>
             <a:r>
               <a:rPr lang="en-US" dirty="0"/>
-              <a:t/>
+              <a:t>Механизм. Около 15% эффекта руководителя и среды идёт через депрессивные симптомы. И модерация: работа опасна только без академической опоры. При сильной принадлежности к кафедре работающие по модели рискуют даже меньше.</a:t>
             </a:r>
             <a:endParaRPr lang="en-US" dirty="0"/>
           </a:p>
@@ -2974,7 +2974,7 @@
           <a:p>
             <a:r>
               <a:rPr lang="en-US" dirty="0"/>
-              <a:t/>
+              <a:t>Вуз тоже важен, хотя на уровне вузов лежит лишь около 4% различий. Самая сильная связь с Мониторингом: где за год защищается больше сотрудников, аспиранты на 30% чаще хотят уйти. Это устойчиво без двух крупнейших вузов. И именно там руководитель важнее всего. Моя интерпретация: давление «защищайся быстрее» без ресурсов.</a:t>
             </a:r>
             <a:endParaRPr lang="en-US" dirty="0"/>
           </a:p>
@@ -3251,7 +3251,7 @@
                   </a:schemeClr>
                 </a:solidFill>
               </a:rPr>
-              <a:t>Данные: Всероссийский опрос аспирантов 2021 (HSE-BR-2025-009); Мониторинг эффективности вузов 2022 (Минобрнауки)</a:t>
+              <a:t>Данные: опрос аспирантов 2021 (HSE-BR-2025-009); Мониторинг эффективности вузов 2022; лонгитюд студентов 2024–2026 (HSE-BR-2025-009)</a:t>
             </a:r>
             <a:endParaRPr lang="en-US" sz="1000" dirty="0"/>
           </a:p>
@@ -3838,7 +3838,7 @@
                   <a:schemeClr val="bg2"/>
                 </a:solidFill>
               </a:rPr>
-              <a:t>Связка двух массивов хакатона: опрос 5 007 аспирантов × Мониторинг эффективности вузов</a:t>
+              <a:t>Все три массива хакатона: опрос 5 007 аспирантов × Мониторинг вузов + репликация на лонгитюде студентов</a:t>
             </a:r>
             <a:endParaRPr lang="en-US" sz="1800" dirty="0"/>
           </a:p>
@@ -4088,7 +4088,7 @@
                   <a:schemeClr val="bg1"/>
                 </a:solidFill>
               </a:rPr>
-              <a:t>Ранний сигнал: короткая анкета находит 20% группы риска</a:t>
+              <a:t>Короткий скрининг (8 показателей, AUC 0.83) находит группу риска заранее</a:t>
             </a:r>
             <a:endParaRPr lang="en-US" sz="1400" dirty="0"/>
           </a:p>
@@ -5122,7 +5122,7 @@
                   <a:schemeClr val="tx2"/>
                 </a:solidFill>
               </a:rPr>
-              <a:t>Данные: два массива хакатона, связанные на уровне вуза</a:t>
+              <a:t>Данные: все три массива хакатона, связанные на уровне вуза</a:t>
             </a:r>
             <a:endParaRPr lang="en-US" sz="2600" dirty="0"/>
           </a:p>
@@ -6046,7 +6046,7 @@
                   <a:schemeClr val="accent1"/>
                 </a:solidFill>
               </a:rPr>
-              <a:t>87%</a:t>
+              <a:t>3 из 3</a:t>
             </a:r>
             <a:endParaRPr lang="en-US" sz="4400" dirty="0"/>
           </a:p>
@@ -6082,7 +6082,7 @@
                   <a:schemeClr val="tx1"/>
                 </a:solidFill>
               </a:rPr>
-              <a:t>анкет с полными ответами для моделей</a:t>
+              <a:t>массивов хакатона: опрос, МЭВ и лонгитюд студентов (для репликации)</a:t>
             </a:r>
             <a:endParaRPr lang="en-US" sz="1400" dirty="0"/>
           </a:p>
@@ -7292,8 +7292,8 @@
           <p:nvPr/>
         </p:nvGraphicFramePr>
         <p:xfrm>
-          <a:off x="548640" y="1783080"/>
-          <a:ext cx="2697480" cy="3520440"/>
+          <a:off x="548640" y="1737360"/>
+          <a:ext cx="2697480" cy="3337560"/>
         </p:xfrm>
         <a:graphic xmlns:a="http://schemas.openxmlformats.org/drawingml/2006/main">
           <a:graphicData uri="http://schemas.openxmlformats.org/drawingml/2006/chart">
@@ -7308,8 +7308,8 @@
           <p:nvPr/>
         </p:nvGraphicFramePr>
         <p:xfrm>
-          <a:off x="3337560" y="1783080"/>
-          <a:ext cx="2697480" cy="3520440"/>
+          <a:off x="3337560" y="1737360"/>
+          <a:ext cx="2697480" cy="3337560"/>
         </p:xfrm>
         <a:graphic xmlns:a="http://schemas.openxmlformats.org/drawingml/2006/main">
           <a:graphicData uri="http://schemas.openxmlformats.org/drawingml/2006/chart">
@@ -7324,8 +7324,8 @@
           <p:nvPr/>
         </p:nvGraphicFramePr>
         <p:xfrm>
-          <a:off x="6126480" y="1783080"/>
-          <a:ext cx="2697480" cy="3520440"/>
+          <a:off x="6126480" y="1737360"/>
+          <a:ext cx="2697480" cy="3337560"/>
         </p:xfrm>
         <a:graphic xmlns:a="http://schemas.openxmlformats.org/drawingml/2006/main">
           <a:graphicData uri="http://schemas.openxmlformats.org/drawingml/2006/chart">
@@ -7340,8 +7340,8 @@
           <p:nvPr/>
         </p:nvGraphicFramePr>
         <p:xfrm>
-          <a:off x="8915400" y="1783080"/>
-          <a:ext cx="2697480" cy="3520440"/>
+          <a:off x="8915400" y="1737360"/>
+          <a:ext cx="2697480" cy="3337560"/>
         </p:xfrm>
         <a:graphic xmlns:a="http://schemas.openxmlformats.org/drawingml/2006/main">
           <a:graphicData uri="http://schemas.openxmlformats.org/drawingml/2006/chart">
@@ -7357,12 +7357,12 @@
         </p:nvSpPr>
         <p:spPr>
           <a:xfrm>
-            <a:off x="548640" y="5440680"/>
-            <a:ext cx="11094415" cy="777240"/>
+            <a:off x="548640" y="5166360"/>
+            <a:ext cx="5410048" cy="1097280"/>
           </a:xfrm>
           <a:prstGeom prst="roundRect">
             <a:avLst>
-              <a:gd name="adj" fmla="val 9412"/>
+              <a:gd name="adj" fmla="val 6667"/>
             </a:avLst>
           </a:prstGeom>
           <a:solidFill>
@@ -7384,8 +7384,8 @@
         </p:nvSpPr>
         <p:spPr>
           <a:xfrm>
-            <a:off x="777240" y="5532120"/>
-            <a:ext cx="10637215" cy="640080"/>
+            <a:off x="731520" y="5257800"/>
+            <a:ext cx="5044288" cy="960120"/>
           </a:xfrm>
           <a:prstGeom prst="rect">
             <a:avLst/>
@@ -7404,12 +7404,12 @@
               <a:buNone/>
             </a:pPr>
             <a:r>
-              <a:rPr lang="en-US" sz="1400" b="1" dirty="0">
+              <a:rPr lang="en-US" sz="1300" b="1" dirty="0">
                 <a:solidFill>
                   <a:schemeClr val="tx1"/>
                 </a:solidFill>
               </a:rPr>
-              <a:t>Парадокс: </a:t>
+              <a:t>Парадокс. </a:t>
             </a:r>
             <a:pPr indent="0" marL="0">
               <a:spcAft>
@@ -7418,14 +7418,94 @@
               <a:buNone/>
             </a:pPr>
             <a:r>
-              <a:rPr lang="en-US" sz="1400" dirty="0">
+              <a:rPr lang="en-US" sz="1300" dirty="0">
                 <a:solidFill>
                   <a:schemeClr val="tx1"/>
                 </a:solidFill>
               </a:rPr>
-              <a:t>45% называют совмещение с работой серьёзной трудностью, но сам факт работы риск не меняет. Сопоставление по склонности (PSM, 1 971 пар): эффект полного дня вне вуза +0.6 п.п. [-1.7; 3.0]. H1 отвергнута.</a:t>
-            </a:r>
-            <a:endParaRPr lang="en-US" sz="1400" dirty="0"/>
+              <a:t>45% называют работу серьёзной трудностью, но сам факт работы риск не меняет. PSM (1 971 пар): +0.6 п.п. [-1.7; 3.0]. H1 отвергнута.</a:t>
+            </a:r>
+            <a:endParaRPr lang="en-US" sz="1300" dirty="0"/>
+          </a:p>
+        </p:txBody>
+      </p:sp>
+      <p:sp>
+        <p:nvSpPr>
+          <p:cNvPr id="10" name="card"/>
+          <p:cNvSpPr/>
+          <p:nvPr/>
+        </p:nvSpPr>
+        <p:spPr>
+          <a:xfrm>
+            <a:off x="6233008" y="5166360"/>
+            <a:ext cx="5410048" cy="1097280"/>
+          </a:xfrm>
+          <a:prstGeom prst="roundRect">
+            <a:avLst>
+              <a:gd name="adj" fmla="val 6667"/>
+            </a:avLst>
+          </a:prstGeom>
+          <a:solidFill>
+            <a:schemeClr val="bg2"/>
+          </a:solidFill>
+          <a:ln w="12700">
+            <a:solidFill>
+              <a:schemeClr val="bg2"/>
+            </a:solidFill>
+            <a:prstDash val="solid"/>
+          </a:ln>
+        </p:spPr>
+      </p:sp>
+      <p:sp>
+        <p:nvSpPr>
+          <p:cNvPr id="11" name="Text 5"/>
+          <p:cNvSpPr txBox="1"/>
+          <p:nvPr/>
+        </p:nvSpPr>
+        <p:spPr>
+          <a:xfrm>
+            <a:off x="6415888" y="5257800"/>
+            <a:ext cx="5044288" cy="960120"/>
+          </a:xfrm>
+          <a:prstGeom prst="rect">
+            <a:avLst/>
+          </a:prstGeom>
+          <a:noFill/>
+          <a:ln/>
+        </p:spPr>
+        <p:txBody>
+          <a:bodyPr wrap="square" lIns="0" tIns="0" rIns="0" bIns="0" rtlCol="0" anchor="t"/>
+          <a:lstStyle/>
+          <a:p>
+            <a:pPr indent="0" marL="0">
+              <a:spcAft>
+                <a:spcPts val="600"/>
+              </a:spcAft>
+              <a:buNone/>
+            </a:pPr>
+            <a:r>
+              <a:rPr lang="en-US" sz="1300" b="1" dirty="0">
+                <a:solidFill>
+                  <a:schemeClr val="tx1"/>
+                </a:solidFill>
+              </a:rPr>
+              <a:t>Репликация на студентах (лонгитюд, 3-й массив). </a:t>
+            </a:r>
+            <a:pPr indent="0" marL="0">
+              <a:spcAft>
+                <a:spcPts val="600"/>
+              </a:spcAft>
+              <a:buNone/>
+            </a:pPr>
+            <a:r>
+              <a:rPr lang="en-US" sz="1300" dirty="0">
+                <a:solidFill>
+                  <a:schemeClr val="tx1"/>
+                </a:solidFill>
+              </a:rPr>
+              <a:t>Начало работы между волнами не повышает мысли об уходе (ОШ 0.87, p = 0.65, n = 564). Решает переживание конфликта: 58% против 36%.</a:t>
+            </a:r>
+            <a:endParaRPr lang="en-US" sz="1300" dirty="0"/>
           </a:p>
         </p:txBody>
       </p:sp>

</xml_diff>